<commit_message>
Actualizacion de los documentos
Los documentos como informe y presentacion fueron actualizado segun los cambios y actualizaciones que se conversaron en clases
</commit_message>
<xml_diff>
--- a/Fase 1/Evidencias Grupales/Proyecto_APT_Presentacion.pptx
+++ b/Fase 1/Evidencias Grupales/Proyecto_APT_Presentacion.pptx
@@ -373,7 +373,7 @@
           <a:p>
             <a:r>
               <a:rPr lang="en-US" dirty="0"/>
-              <a:t>Los tres pilares del sistema. Enfatizar que la facturación SII es obligatoria en todos los planes: es una restricción de arquitectura, no una función opcional.</a:t>
+              <a:t>Los tres pilares del sistema. Enfatizar la regla de oro: la venta nunca se bloquea (offline-first). El comprobante se emite al instante (emisión simulada); la integración con el SII queda como trabajo futuro.</a:t>
             </a:r>
           </a:p>
         </p:txBody>
@@ -547,7 +547,7 @@
           <a:p>
             <a:r>
               <a:rPr lang="en-US" dirty="0"/>
-              <a:t>Cerrar reforzando la regla de oro: la facturación SII es transversal a todos los planes.</a:t>
+              <a:t>Cerrar reforzando la regla de oro: la operación offline y el comprobante de venta están en los tres planes; la primera caja va incluida.</a:t>
             </a:r>
           </a:p>
         </p:txBody>
@@ -1058,7 +1058,7 @@
                 <a:ea typeface="Cambria" pitchFamily="34" charset="-122"/>
                 <a:cs typeface="Cambria" pitchFamily="34" charset="-120"/>
               </a:rPr>
-              <a:t>Plataforma de bodega y</a:t>
+              <a:t>Bodega, punto de venta y</a:t>
             </a:r>
             <a:endParaRPr lang="en-US" sz="4000" dirty="0"/>
           </a:p>
@@ -1078,7 +1078,7 @@
                 <a:ea typeface="Cambria" pitchFamily="34" charset="-122"/>
                 <a:cs typeface="Cambria" pitchFamily="34" charset="-120"/>
               </a:rPr>
-              <a:t>facturación electrónica</a:t>
+              <a:t>comprobante, sin internet</a:t>
             </a:r>
             <a:endParaRPr lang="en-US" sz="4000" dirty="0"/>
           </a:p>
@@ -1117,7 +1117,7 @@
                 <a:ea typeface="Calibri" pitchFamily="34" charset="-122"/>
                 <a:cs typeface="Calibri" pitchFamily="34" charset="-120"/>
               </a:rPr>
-              <a:t>con punto de venta integrado, para el comercio minorista chileno</a:t>
+              <a:t>Caja offline que sincroniza a la nube, para el comercio minorista chileno</a:t>
             </a:r>
             <a:endParaRPr lang="en-US" sz="1500" dirty="0"/>
           </a:p>
@@ -1417,7 +1417,7 @@
                 <a:ea typeface="Calibri" pitchFamily="34" charset="-122"/>
                 <a:cs typeface="Calibri" pitchFamily="34" charset="-120"/>
               </a:rPr>
-              <a:t>Una plataforma web entregada como servicio (SaaS) que reúne en un solo sistema el control de bodega, la facturación electrónica ante el SII y el punto de venta.</a:t>
+              <a:t>Un sistema que reúne en un solo equipo el control de bodega, el punto de venta y la emisión del comprobante de venta, y que funciona sin internet dentro del local.</a:t>
             </a:r>
             <a:endParaRPr lang="en-US" sz="1400" dirty="0"/>
           </a:p>
@@ -1440,7 +1440,7 @@
                 <a:ea typeface="Calibri" pitchFamily="34" charset="-122"/>
                 <a:cs typeface="Calibri" pitchFamily="34" charset="-120"/>
               </a:rPr>
-              <a:t>Es multi-tenant: una sola instancia atiende a muchos negocios, aislando los datos de cada uno. Se adapta al tamaño del comercio mediante tres planes escalables.</a:t>
+              <a:t>La caja corre en el local (offline-first) y sincroniza a una nube multi-tenant que atiende a muchos negocios aislando los datos de cada uno. Se adapta al comercio con tres planes escalables.</a:t>
             </a:r>
             <a:endParaRPr lang="en-US" sz="1400" dirty="0"/>
           </a:p>
@@ -1460,7 +1460,7 @@
                 <a:ea typeface="Calibri" pitchFamily="34" charset="-122"/>
                 <a:cs typeface="Calibri" pitchFamily="34" charset="-120"/>
               </a:rPr>
-              <a:t>Le da a un almacén o minimarket el mismo control de stock y cumplimiento tributario que opera un supermercado, sin el peso administrativo de un ERP.</a:t>
+              <a:t>Le da a un almacén o minimarket el mismo control de stock y de caja que tiene un supermercado, sin el peso administrativo de un ERP.</a:t>
             </a:r>
             <a:endParaRPr lang="en-US" sz="1400" dirty="0"/>
           </a:p>
@@ -1808,7 +1808,7 @@
                 <a:ea typeface="Calibri" pitchFamily="34" charset="-122"/>
                 <a:cs typeface="Calibri" pitchFamily="34" charset="-120"/>
               </a:rPr>
-              <a:t>Facturación electrónica SII</a:t>
+              <a:t>Comprobante de venta</a:t>
             </a:r>
             <a:endParaRPr lang="en-US" sz="1350" dirty="0"/>
           </a:p>
@@ -1850,7 +1850,7 @@
                 <a:ea typeface="Calibri" pitchFamily="34" charset="-122"/>
                 <a:cs typeface="Calibri" pitchFamily="34" charset="-120"/>
               </a:rPr>
-              <a:t>Boleta, factura, nota de crédito y guía de despacho como DTE. Obligatoria en todos los planes.</a:t>
+              <a:t>Numeración correlativa y cola de emisión con reintentos (emisión simulada en esta versión). La integración con el SII queda como trabajo futuro.</a:t>
             </a:r>
             <a:endParaRPr lang="en-US" sz="1050" dirty="0"/>
           </a:p>
@@ -2031,7 +2031,7 @@
                 <a:ea typeface="Calibri" pitchFamily="34" charset="-122"/>
                 <a:cs typeface="Calibri" pitchFamily="34" charset="-120"/>
               </a:rPr>
-              <a:t>La venta descuenta stock y emite el documento; apertura y cierre de caja.</a:t>
+              <a:t>La venta descuenta stock y emite el comprobante; apertura y cierre de caja.</a:t>
             </a:r>
             <a:endParaRPr lang="en-US" sz="1050" dirty="0"/>
           </a:p>
@@ -2351,7 +2351,7 @@
                 <a:ea typeface="Calibri" pitchFamily="34" charset="-122"/>
                 <a:cs typeface="Calibri" pitchFamily="34" charset="-120"/>
               </a:rPr>
-              <a:t>Facturación electrónica SII: boleta (39), factura afecta (33), exenta (34), nota de crédito (61) y guía de despacho (52).</a:t>
+              <a:t>Comprobante de venta: numeración correlativa y cola de emisión con reintentos (emisión simulada).</a:t>
             </a:r>
             <a:endParaRPr lang="en-US" sz="1150" dirty="0"/>
           </a:p>
@@ -2375,7 +2375,7 @@
                 <a:ea typeface="Calibri" pitchFamily="34" charset="-122"/>
                 <a:cs typeface="Calibri" pitchFamily="34" charset="-120"/>
               </a:rPr>
-              <a:t>Punto de venta y caja: venta con descuento de stock, emisión del documento, apertura y cierre.</a:t>
+              <a:t>Punto de venta y caja offline: la venta nunca se bloquea; descuenta stock y emite el comprobante.</a:t>
             </a:r>
             <a:endParaRPr lang="en-US" sz="1150" dirty="0"/>
           </a:p>
@@ -2399,7 +2399,7 @@
                 <a:ea typeface="Calibri" pitchFamily="34" charset="-122"/>
                 <a:cs typeface="Calibri" pitchFamily="34" charset="-120"/>
               </a:rPr>
-              <a:t>Usuarios y roles, planes y reportes de ventas.</a:t>
+              <a:t>Multi-tenant: panel de administración y de cliente, usuarios y roles.</a:t>
             </a:r>
             <a:endParaRPr lang="en-US" sz="1150" dirty="0"/>
           </a:p>
@@ -2722,7 +2722,7 @@
                 <a:ea typeface="Calibri" pitchFamily="34" charset="-122"/>
                 <a:cs typeface="Calibri" pitchFamily="34" charset="-120"/>
               </a:rPr>
-              <a:t>Modo on-premise sin internet: extensión futura, fuera del semestre.</a:t>
+              <a:t>Integración real con el SII (firma y envío de DTE): trabajo futuro, fuera del alcance.</a:t>
             </a:r>
             <a:endParaRPr lang="en-US" sz="1150" dirty="0"/>
           </a:p>
@@ -3020,7 +3020,7 @@
                 <a:ea typeface="Calibri" pitchFamily="34" charset="-122"/>
                 <a:cs typeface="Calibri" pitchFamily="34" charset="-120"/>
               </a:rPr>
-              <a:t>Inventario simple, punto de venta, caja y facturación electrónica.</a:t>
+              <a:t>Inventario simple, punto de venta, caja y comprobante — funciona offline.</a:t>
             </a:r>
             <a:endParaRPr lang="en-US" sz="1100" dirty="0"/>
           </a:p>
@@ -3120,7 +3120,7 @@
                 <a:ea typeface="Calibri" pitchFamily="34" charset="-122"/>
                 <a:cs typeface="Calibri" pitchFamily="34" charset="-120"/>
               </a:rPr>
-              <a:t>Minisúper</a:t>
+              <a:t>Minimarket</a:t>
             </a:r>
             <a:endParaRPr lang="en-US" sz="1800" dirty="0"/>
           </a:p>
@@ -3304,7 +3304,7 @@
                 <a:ea typeface="Calibri" pitchFamily="34" charset="-122"/>
                 <a:cs typeface="Calibri" pitchFamily="34" charset="-120"/>
               </a:rPr>
-              <a:t>Supermercado</a:t>
+              <a:t>Minisúper</a:t>
             </a:r>
             <a:endParaRPr lang="en-US" sz="1800" dirty="0"/>
           </a:p>
@@ -3346,7 +3346,7 @@
                 <a:ea typeface="Calibri" pitchFamily="34" charset="-122"/>
                 <a:cs typeface="Calibri" pitchFamily="34" charset="-120"/>
               </a:rPr>
-              <a:t>Operación grande, con sucursales</a:t>
+              <a:t>Varias cajas o sucursales</a:t>
             </a:r>
             <a:endParaRPr lang="en-US" sz="1050" dirty="0"/>
           </a:p>
@@ -3427,7 +3427,7 @@
                 <a:ea typeface="Calibri" pitchFamily="34" charset="-122"/>
                 <a:cs typeface="Calibri" pitchFamily="34" charset="-120"/>
               </a:rPr>
-              <a:t>La facturación electrónica ante el SII es obligatoria en los tres planes.</a:t>
+              <a:t>El comprobante de venta y la operación offline están en los tres planes; la primera caja va incluida.</a:t>
             </a:r>
             <a:endParaRPr lang="en-US" sz="1150" dirty="0"/>
           </a:p>

</xml_diff>